<commit_message>
Use real presenter names and make Sprechtext sound natural
- Replace Person A/B/C placeholders everywhere with the actual
  presenters: Max Manahl, Simon Schick, Daniel Kornfeld (title slide,
  closing slide, corner name badges, speaker notes)
- Widen and resize the corner name badge to fit full names
- Rewrite the speaker script (sprechtext.md/.docx) to sound like
  natural spoken German instead of a stiff script: dropped the
  repetitive "Übergabe an X" tag, loosened formal listy phrasing,
  varied transitions, used first names in dialogue
</commit_message>
<xml_diff>
--- a/kombinatorik-praesentation/kombinatorik_praesentation.pptx
+++ b/kombinatorik-praesentation/kombinatorik_praesentation.pptx
@@ -589,7 +589,7 @@
           <a:lstStyle/>
           <a:p>
             <a:r>
-              <a:t>Person C erklärt kurz die Spielregeln und erzeugt Spannung. Wichtig: Schätzungen werden im Kopf behalten oder auf einen Zettel geschrieben – KEIN Taschenrechner, KEIN Gespräch! Dann Überleitung zu Person A für Runde 1.</a:t>
+              <a:t>Daniel erklärt kurz die Spielregeln und erzeugt Spannung. Wichtig: Schätzungen werden im Kopf behalten oder auf einen Zettel geschrieben – KEIN Taschenrechner, KEIN Gespräch! Dann Überleitung zu Max für Runde 1.</a:t>
             </a:r>
           </a:p>
         </p:txBody>
@@ -659,7 +659,7 @@
           <a:lstStyle/>
           <a:p>
             <a:r>
-              <a:t>Person A liest die Frage vor und gibt 30-45 Sekunden Zeit zum Schätzen. Dann kurze Handshow: 'Wer schätzt unter 1.000? Unter 1 Million? Über 1 Milliarde?' Spannung erzeugen, dann Überleitung zu Person B für die Auflösung.</a:t>
+              <a:t>Max liest die Frage vor und gibt 30-45 Sekunden Zeit zum Schätzen. Dann kurze Handshow: 'Wer schätzt unter 1.000? Unter 1 Million? Über 1 Milliarde?' Spannung erzeugen, dann Überleitung zu Simon für die Auflösung.</a:t>
             </a:r>
           </a:p>
         </p:txBody>
@@ -729,7 +729,7 @@
           <a:lstStyle/>
           <a:p>
             <a:r>
-              <a:t>Person B enthüllt die Auflösung: 15! = 1.307.674.368.000 ≈ 1,3 Billionen! Den 'Steinzeit-Vergleich' als Anker verwenden: seit ca. 39.000 v. Chr. eine Reihenfolge pro Sekunde – und man wäre gerade fertig (Homo sapiens war damals gerade auf dem Weg nach Europa!). Kurzes 'WOW' abwarten. Überleitung zu Person C für Runde 2.</a:t>
+              <a:t>Simon enthüllt die Auflösung: 15! = 1.307.674.368.000 ≈ 1,3 Billionen! Den 'Steinzeit-Vergleich' als Anker verwenden: seit ca. 39.000 v. Chr. eine Reihenfolge pro Sekunde – und man wäre gerade fertig (Homo sapiens war damals gerade auf dem Weg nach Europa!). Kurzes 'WOW' abwarten. Überleitung zu Daniel für Runde 2.</a:t>
             </a:r>
           </a:p>
         </p:txBody>
@@ -799,7 +799,7 @@
           <a:lstStyle/>
           <a:p>
             <a:r>
-              <a:t>Person C liest die Frage vor. Diesmal gibt es einen Tipp ('Permutation von 52') damit die Klasse annähernd die Größenordnung einschätzen kann. Gleich: Handshow-Schätzung 'Wer sagt mehr als 1.000? 1 Million? 1 Milliarde? 1 Trillion?' Überleitung zu Person A für die Auflösung.</a:t>
+              <a:t>Daniel liest die Frage vor. Diesmal gibt es einen Tipp ('Permutation von 52') damit die Klasse annähernd die Größenordnung einschätzen kann. Gleich: Handshow-Schätzung 'Wer sagt mehr als 1.000? 1 Million? 1 Milliarde? 1 Trillion?' Überleitung zu Max für die Auflösung.</a:t>
             </a:r>
           </a:p>
         </p:txBody>
@@ -869,7 +869,7 @@
           <a:lstStyle/>
           <a:p>
             <a:r>
-              <a:t>Person A enthüllt 52! ≈ 8,07×10^67. Die drei Bullet-Points nacheinander vorlesen und kurze Pause danach lassen – das 'Fazit' ist ein echter Gesprächsstarter. Überleitung zu Person B: 'Jetzt fassen wir alles nochmal kompakt zusammen – welche Formel, wann?'</a:t>
+              <a:t>Max enthüllt 52! ≈ 8,07×10^67. Die drei Bullet-Points nacheinander vorlesen und kurze Pause danach lassen – das 'Fazit' ist ein echter Gesprächsstarter. Überleitung zu Simon: 'Jetzt fassen wir alles nochmal kompakt zusammen – welche Formel, wann?'</a:t>
             </a:r>
           </a:p>
         </p:txBody>
@@ -939,7 +939,7 @@
           <a:lstStyle/>
           <a:p>
             <a:r>
-              <a:t>Person B fasst alle 5 Konzepte in der Entscheidungstabelle zusammen. Die zwei Fragen (Reihenfolge? Wiederholung?) direkt nennen – das ist der Matura-Trick, der immer funktioniert. Überleitung zu allen drei für die Zusammenfassung.</a:t>
+              <a:t>Simon fasst alle 5 Konzepte in der Entscheidungstabelle zusammen. Die zwei Fragen (Reihenfolge? Wiederholung?) direkt nennen – das ist der Matura-Trick, der immer funktioniert. Überleitung zu allen drei für die Zusammenfassung.</a:t>
             </a:r>
           </a:p>
         </p:txBody>
@@ -1219,7 +1219,7 @@
           <a:lstStyle/>
           <a:p>
             <a:r>
-              <a:t>Person A stellt die Agenda vor und präsentiert die drei Gedankenexperiment-Fragen. Kurze Pause nach jeder Frage – das Publikum soll mental schätzen, NICHT laut antworten. Sagen: 'Diese drei Fragen werden wir heute Schritt für Schritt beantworten!' Überleitung zu Person B für das Zählprinzip.</a:t>
+              <a:t>Max stellt die Agenda vor und präsentiert die drei Gedankenexperiment-Fragen. Kurze Pause nach jeder Frage – das Publikum soll mental schätzen, NICHT laut antworten. Sagen: 'Diese drei Fragen werden wir heute Schritt für Schritt beantworten!' Überleitung zu Simon für das Zählprinzip.</a:t>
             </a:r>
           </a:p>
         </p:txBody>
@@ -1289,7 +1289,7 @@
           <a:lstStyle/>
           <a:p>
             <a:r>
-              <a:t>Person B erklärt das Zählprinzip am Outfit-Beispiel: 3×4=12 Hemd-Hosen-Kombinationen, jede davon × 2 Schuhe = 24. Das Raster macht das visuell greifbar. Betonen: Das Zählprinzip ist die GRUNDLAGE für Permutation, Variation und Kombination! Überleitung zu Person C.</a:t>
+              <a:t>Simon erklärt das Zählprinzip am Outfit-Beispiel: 3×4=12 Hemd-Hosen-Kombinationen, jede davon × 2 Schuhe = 24. Das Raster macht das visuell greifbar. Betonen: Das Zählprinzip ist die GRUNDLAGE für Permutation, Variation und Kombination! Überleitung zu Daniel.</a:t>
             </a:r>
           </a:p>
         </p:txBody>
@@ -1359,7 +1359,7 @@
           <a:lstStyle/>
           <a:p>
             <a:r>
-              <a:t>Person C erklärt Permutation ohne Wiederholung (Baumdiagramm, 3 Freunde = 6 Reihenfolgen, dann 5 Personen = 5!=120). Danach ANANAS mit Wiederholung: 6 Buchstaben, A kommt 3x, N 2x vor → 6!/(3!·2!·1!)=60. Überleitung zu Person A.</a:t>
+              <a:t>Daniel erklärt Permutation ohne Wiederholung (Baumdiagramm, 3 Freunde = 6 Reihenfolgen, dann 5 Personen = 5!=120). Danach ANANAS mit Wiederholung: 6 Buchstaben, A kommt 3x, N 2x vor → 6!/(3!·2!·1!)=60. Überleitung zu Max.</a:t>
             </a:r>
           </a:p>
         </p:txBody>
@@ -1429,7 +1429,7 @@
           <a:lstStyle/>
           <a:p>
             <a:r>
-              <a:t>Person A erklärt Variation ohne Wiederholung (Stockerlplatz: 8 Läufer, nur 3 Plätze, Reihenfolge zählt → V(8,3)=336). Dann Variation MIT Wiederholung und die Auflösung der ersten Gedankenexperiment-Frage: 10^4 = 10.000 PINs! Überleitung zu Person B.</a:t>
+              <a:t>Max erklärt Variation ohne Wiederholung (Stockerlplatz: 8 Läufer, nur 3 Plätze, Reihenfolge zählt → V(8,3)=336). Dann Variation MIT Wiederholung und die Auflösung der ersten Gedankenexperiment-Frage: 10^4 = 10.000 PINs! Überleitung zu Simon.</a:t>
             </a:r>
           </a:p>
         </p:txBody>
@@ -1499,7 +1499,7 @@
           <a:lstStyle/>
           <a:p>
             <a:r>
-              <a:t>Person B erklärt Kombination ohne Wiederholung am Handynummer-Beispiel: 15 Schüler:innen, Reihenfolge egal → C(15,2) = 105 Austausche! Viele Leute erwarten ~15 oder ~30 – 105 überrascht. Das ist die Auflösung von Frage 2! Dann Kombination MIT Wiederholung (Eisbecher). Überleitung zu Person C.</a:t>
+              <a:t>Simon erklärt Kombination ohne Wiederholung am Handynummer-Beispiel: 15 Schüler:innen, Reihenfolge egal → C(15,2) = 105 Austausche! Viele Leute erwarten ~15 oder ~30 – 105 überrascht. Das ist die Auflösung von Frage 2! Dann Kombination MIT Wiederholung (Eisbecher). Überleitung zu Daniel.</a:t>
             </a:r>
           </a:p>
         </p:txBody>
@@ -1569,7 +1569,7 @@
           <a:lstStyle/>
           <a:p>
             <a:r>
-              <a:t>Person C zeigt das Pascal'sche Dreieck: jede Zahl = Summe der zwei Zahlen darüber (Rekursionsformel). Die orange 15 = binom(6,2) – direkte Verbindung zu Kombination. Das Dreieck ist eine fertige Tabelle für alle Binomialkoeffizienten. Überleitung zu Person A.</a:t>
+              <a:t>Daniel zeigt das Pascal'sche Dreieck: jede Zahl = Summe der zwei Zahlen darüber (Rekursionsformel). Die orange 15 = binom(6,2) – direkte Verbindung zu Kombination. Das Dreieck ist eine fertige Tabelle für alle Binomialkoeffizienten. Überleitung zu Max.</a:t>
             </a:r>
           </a:p>
         </p:txBody>
@@ -1639,7 +1639,7 @@
           <a:lstStyle/>
           <a:p>
             <a:r>
-              <a:t>Person A führt die Laplace-Wahrscheinlichkeit ein: P(A)=|A|/|Omega|. Sofort am Beispiel demonstrieren: Würfelpasch. |Omega|=36 (Zählprinzip!), |A|=6 (Diagonale). P(Pasch)=6/36=1/6. Betonen: Kombinatorik UND Wahrscheinlichkeit hängen direkt zusammen. Überleitung zu Person B.</a:t>
+              <a:t>Max führt die Laplace-Wahrscheinlichkeit ein: P(A)=|A|/|Omega|. Sofort am Beispiel demonstrieren: Würfelpasch. |Omega|=36 (Zählprinzip!), |A|=6 (Diagonale). P(Pasch)=6/36=1/6. Betonen: Kombinatorik UND Wahrscheinlichkeit hängen direkt zusammen. Überleitung zu Simon.</a:t>
             </a:r>
           </a:p>
         </p:txBody>
@@ -1709,7 +1709,7 @@
           <a:lstStyle/>
           <a:p>
             <a:r>
-              <a:t>Person B löst die dritte Gedankenexperiment-Frage auf: P(6 Richtige)=1/8.145.060. Den Österreich-Vergleich nutzen, um die Größenordnung greifbar zu machen. Jetzt alle 3 Fragen beantwortet – kurze Pause, dann Überleitung zu Person C für den praktischen Teil.</a:t>
+              <a:t>Simon löst die dritte Gedankenexperiment-Frage auf: P(6 Richtige)=1/8.145.060. Den Österreich-Vergleich nutzen, um die Größenordnung greifbar zu machen. Jetzt alle 3 Fragen beantwortet – kurze Pause, dann Überleitung zu Daniel für den praktischen Teil.</a:t>
             </a:r>
           </a:p>
         </p:txBody>
@@ -4998,7 +4998,7 @@
                 </a:solidFill>
                 <a:latin typeface="Calibri"/>
               </a:rPr>
-              <a:t>Vorgetragen von Person A, Person B &amp; Person C</a:t>
+              <a:t>Vorgetragen von Max Manahl, Simon Schick &amp; Daniel Kornfeld</a:t>
             </a:r>
           </a:p>
         </p:txBody>
@@ -5213,8 +5213,8 @@
         </p:nvSpPr>
         <p:spPr>
           <a:xfrm>
-            <a:off x="10454335" y="329184"/>
-            <a:ext cx="1417320" cy="384048"/>
+            <a:off x="9951415" y="329184"/>
+            <a:ext cx="1920240" cy="384048"/>
           </a:xfrm>
           <a:prstGeom prst="roundRect">
             <a:avLst>
@@ -5251,13 +5251,13 @@
               <a:buNone/>
             </a:pPr>
             <a:r>
-              <a:rPr sz="1300" b="1">
+              <a:rPr sz="1200" b="1">
                 <a:solidFill>
                   <a:srgbClr val="2563EB"/>
                 </a:solidFill>
                 <a:latin typeface="Calibri"/>
               </a:rPr>
-              <a:t>Person C</a:t>
+              <a:t>Daniel Kornfeld</a:t>
             </a:r>
           </a:p>
         </p:txBody>
@@ -5736,8 +5736,8 @@
         </p:nvSpPr>
         <p:spPr>
           <a:xfrm>
-            <a:off x="10454335" y="329184"/>
-            <a:ext cx="1417320" cy="384048"/>
+            <a:off x="9951415" y="329184"/>
+            <a:ext cx="1920240" cy="384048"/>
           </a:xfrm>
           <a:prstGeom prst="roundRect">
             <a:avLst>
@@ -5774,13 +5774,13 @@
               <a:buNone/>
             </a:pPr>
             <a:r>
-              <a:rPr sz="1300" b="1">
+              <a:rPr sz="1200" b="1">
                 <a:solidFill>
                   <a:srgbClr val="1E3A8A"/>
                 </a:solidFill>
                 <a:latin typeface="Calibri"/>
               </a:rPr>
-              <a:t>Person A</a:t>
+              <a:t>Max Manahl</a:t>
             </a:r>
           </a:p>
         </p:txBody>
@@ -6239,8 +6239,8 @@
         </p:nvSpPr>
         <p:spPr>
           <a:xfrm>
-            <a:off x="10454335" y="329184"/>
-            <a:ext cx="1417320" cy="384048"/>
+            <a:off x="9951415" y="329184"/>
+            <a:ext cx="1920240" cy="384048"/>
           </a:xfrm>
           <a:prstGeom prst="roundRect">
             <a:avLst>
@@ -6277,13 +6277,13 @@
               <a:buNone/>
             </a:pPr>
             <a:r>
-              <a:rPr sz="1300" b="1">
+              <a:rPr sz="1200" b="1">
                 <a:solidFill>
                   <a:srgbClr val="EA580C"/>
                 </a:solidFill>
                 <a:latin typeface="Calibri"/>
               </a:rPr>
-              <a:t>Person B</a:t>
+              <a:t>Simon Schick</a:t>
             </a:r>
           </a:p>
         </p:txBody>
@@ -6951,8 +6951,8 @@
         </p:nvSpPr>
         <p:spPr>
           <a:xfrm>
-            <a:off x="10454335" y="329184"/>
-            <a:ext cx="1417320" cy="384048"/>
+            <a:off x="9951415" y="329184"/>
+            <a:ext cx="1920240" cy="384048"/>
           </a:xfrm>
           <a:prstGeom prst="roundRect">
             <a:avLst>
@@ -6989,13 +6989,13 @@
               <a:buNone/>
             </a:pPr>
             <a:r>
-              <a:rPr sz="1300" b="1">
+              <a:rPr sz="1200" b="1">
                 <a:solidFill>
                   <a:srgbClr val="2563EB"/>
                 </a:solidFill>
                 <a:latin typeface="Calibri"/>
               </a:rPr>
-              <a:t>Person C</a:t>
+              <a:t>Daniel Kornfeld</a:t>
             </a:r>
           </a:p>
         </p:txBody>
@@ -7454,8 +7454,8 @@
         </p:nvSpPr>
         <p:spPr>
           <a:xfrm>
-            <a:off x="10454335" y="329184"/>
-            <a:ext cx="1417320" cy="384048"/>
+            <a:off x="9951415" y="329184"/>
+            <a:ext cx="1920240" cy="384048"/>
           </a:xfrm>
           <a:prstGeom prst="roundRect">
             <a:avLst>
@@ -7492,13 +7492,13 @@
               <a:buNone/>
             </a:pPr>
             <a:r>
-              <a:rPr sz="1300" b="1">
+              <a:rPr sz="1200" b="1">
                 <a:solidFill>
                   <a:srgbClr val="1E3A8A"/>
                 </a:solidFill>
                 <a:latin typeface="Calibri"/>
               </a:rPr>
-              <a:t>Person A</a:t>
+              <a:t>Max Manahl</a:t>
             </a:r>
           </a:p>
         </p:txBody>
@@ -8023,8 +8023,8 @@
         </p:nvSpPr>
         <p:spPr>
           <a:xfrm>
-            <a:off x="10454335" y="329184"/>
-            <a:ext cx="1417320" cy="384048"/>
+            <a:off x="9951415" y="329184"/>
+            <a:ext cx="1920240" cy="384048"/>
           </a:xfrm>
           <a:prstGeom prst="roundRect">
             <a:avLst>
@@ -8061,13 +8061,13 @@
               <a:buNone/>
             </a:pPr>
             <a:r>
-              <a:rPr sz="1300" b="1">
+              <a:rPr sz="1200" b="1">
                 <a:solidFill>
                   <a:srgbClr val="EA580C"/>
                 </a:solidFill>
                 <a:latin typeface="Calibri"/>
               </a:rPr>
-              <a:t>Person B</a:t>
+              <a:t>Simon Schick</a:t>
             </a:r>
           </a:p>
         </p:txBody>
@@ -8911,8 +8911,8 @@
         </p:nvSpPr>
         <p:spPr>
           <a:xfrm>
-            <a:off x="10454335" y="329184"/>
-            <a:ext cx="1417320" cy="384048"/>
+            <a:off x="9951415" y="329184"/>
+            <a:ext cx="1920240" cy="384048"/>
           </a:xfrm>
           <a:prstGeom prst="roundRect">
             <a:avLst>
@@ -8949,7 +8949,7 @@
               <a:buNone/>
             </a:pPr>
             <a:r>
-              <a:rPr sz="1300" b="1">
+              <a:rPr sz="1200" b="1">
                 <a:solidFill>
                   <a:srgbClr val="64748B"/>
                 </a:solidFill>
@@ -9584,8 +9584,8 @@
         </p:nvSpPr>
         <p:spPr>
           <a:xfrm>
-            <a:off x="10454335" y="329184"/>
-            <a:ext cx="1417320" cy="384048"/>
+            <a:off x="9951415" y="329184"/>
+            <a:ext cx="1920240" cy="384048"/>
           </a:xfrm>
           <a:prstGeom prst="roundRect">
             <a:avLst>
@@ -9622,7 +9622,7 @@
               <a:buNone/>
             </a:pPr>
             <a:r>
-              <a:rPr sz="1300" b="1">
+              <a:rPr sz="1200" b="1">
                 <a:solidFill>
                   <a:srgbClr val="64748B"/>
                 </a:solidFill>
@@ -10083,7 +10083,7 @@
                 </a:solidFill>
                 <a:latin typeface="Calibri"/>
               </a:rPr>
-              <a:t>Person A  ·  Person B  ·  Person C</a:t>
+              <a:t>Max Manahl  ·  Simon Schick  ·  Daniel Kornfeld</a:t>
             </a:r>
           </a:p>
         </p:txBody>
@@ -10261,8 +10261,8 @@
         </p:nvSpPr>
         <p:spPr>
           <a:xfrm>
-            <a:off x="10454335" y="329184"/>
-            <a:ext cx="1417320" cy="384048"/>
+            <a:off x="9951415" y="329184"/>
+            <a:ext cx="1920240" cy="384048"/>
           </a:xfrm>
           <a:prstGeom prst="roundRect">
             <a:avLst>
@@ -10299,13 +10299,13 @@
               <a:buNone/>
             </a:pPr>
             <a:r>
-              <a:rPr sz="1300" b="1">
+              <a:rPr sz="1200" b="1">
                 <a:solidFill>
                   <a:srgbClr val="1E3A8A"/>
                 </a:solidFill>
                 <a:latin typeface="Calibri"/>
               </a:rPr>
-              <a:t>Person A</a:t>
+              <a:t>Max Manahl</a:t>
             </a:r>
           </a:p>
         </p:txBody>
@@ -11078,8 +11078,8 @@
         </p:nvSpPr>
         <p:spPr>
           <a:xfrm>
-            <a:off x="10454335" y="329184"/>
-            <a:ext cx="1417320" cy="384048"/>
+            <a:off x="9951415" y="329184"/>
+            <a:ext cx="1920240" cy="384048"/>
           </a:xfrm>
           <a:prstGeom prst="roundRect">
             <a:avLst>
@@ -11116,13 +11116,13 @@
               <a:buNone/>
             </a:pPr>
             <a:r>
-              <a:rPr sz="1300" b="1">
+              <a:rPr sz="1200" b="1">
                 <a:solidFill>
                   <a:srgbClr val="EA580C"/>
                 </a:solidFill>
                 <a:latin typeface="Calibri"/>
               </a:rPr>
-              <a:t>Person B</a:t>
+              <a:t>Simon Schick</a:t>
             </a:r>
           </a:p>
         </p:txBody>
@@ -11637,8 +11637,8 @@
         </p:nvSpPr>
         <p:spPr>
           <a:xfrm>
-            <a:off x="10454335" y="329184"/>
-            <a:ext cx="1417320" cy="384048"/>
+            <a:off x="9951415" y="329184"/>
+            <a:ext cx="1920240" cy="384048"/>
           </a:xfrm>
           <a:prstGeom prst="roundRect">
             <a:avLst>
@@ -11675,13 +11675,13 @@
               <a:buNone/>
             </a:pPr>
             <a:r>
-              <a:rPr sz="1300" b="1">
+              <a:rPr sz="1200" b="1">
                 <a:solidFill>
                   <a:srgbClr val="2563EB"/>
                 </a:solidFill>
                 <a:latin typeface="Calibri"/>
               </a:rPr>
-              <a:t>Person C</a:t>
+              <a:t>Daniel Kornfeld</a:t>
             </a:r>
           </a:p>
         </p:txBody>
@@ -12454,8 +12454,8 @@
         </p:nvSpPr>
         <p:spPr>
           <a:xfrm>
-            <a:off x="10454335" y="329184"/>
-            <a:ext cx="1417320" cy="384048"/>
+            <a:off x="9951415" y="329184"/>
+            <a:ext cx="1920240" cy="384048"/>
           </a:xfrm>
           <a:prstGeom prst="roundRect">
             <a:avLst>
@@ -12492,13 +12492,13 @@
               <a:buNone/>
             </a:pPr>
             <a:r>
-              <a:rPr sz="1300" b="1">
+              <a:rPr sz="1200" b="1">
                 <a:solidFill>
                   <a:srgbClr val="1E3A8A"/>
                 </a:solidFill>
                 <a:latin typeface="Calibri"/>
               </a:rPr>
-              <a:t>Person A</a:t>
+              <a:t>Max Manahl</a:t>
             </a:r>
           </a:p>
         </p:txBody>
@@ -13484,8 +13484,8 @@
         </p:nvSpPr>
         <p:spPr>
           <a:xfrm>
-            <a:off x="10454335" y="329184"/>
-            <a:ext cx="1417320" cy="384048"/>
+            <a:off x="9951415" y="329184"/>
+            <a:ext cx="1920240" cy="384048"/>
           </a:xfrm>
           <a:prstGeom prst="roundRect">
             <a:avLst>
@@ -13522,13 +13522,13 @@
               <a:buNone/>
             </a:pPr>
             <a:r>
-              <a:rPr sz="1300" b="1">
+              <a:rPr sz="1200" b="1">
                 <a:solidFill>
                   <a:srgbClr val="EA580C"/>
                 </a:solidFill>
                 <a:latin typeface="Calibri"/>
               </a:rPr>
-              <a:t>Person B</a:t>
+              <a:t>Simon Schick</a:t>
             </a:r>
           </a:p>
         </p:txBody>
@@ -14290,8 +14290,8 @@
         </p:nvSpPr>
         <p:spPr>
           <a:xfrm>
-            <a:off x="10454335" y="329184"/>
-            <a:ext cx="1417320" cy="384048"/>
+            <a:off x="9951415" y="329184"/>
+            <a:ext cx="1920240" cy="384048"/>
           </a:xfrm>
           <a:prstGeom prst="roundRect">
             <a:avLst>
@@ -14328,13 +14328,13 @@
               <a:buNone/>
             </a:pPr>
             <a:r>
-              <a:rPr sz="1300" b="1">
+              <a:rPr sz="1200" b="1">
                 <a:solidFill>
                   <a:srgbClr val="2563EB"/>
                 </a:solidFill>
                 <a:latin typeface="Calibri"/>
               </a:rPr>
-              <a:t>Person C</a:t>
+              <a:t>Daniel Kornfeld</a:t>
             </a:r>
           </a:p>
         </p:txBody>
@@ -14878,8 +14878,8 @@
         </p:nvSpPr>
         <p:spPr>
           <a:xfrm>
-            <a:off x="10454335" y="329184"/>
-            <a:ext cx="1417320" cy="384048"/>
+            <a:off x="9951415" y="329184"/>
+            <a:ext cx="1920240" cy="384048"/>
           </a:xfrm>
           <a:prstGeom prst="roundRect">
             <a:avLst>
@@ -14916,13 +14916,13 @@
               <a:buNone/>
             </a:pPr>
             <a:r>
-              <a:rPr sz="1300" b="1">
+              <a:rPr sz="1200" b="1">
                 <a:solidFill>
                   <a:srgbClr val="1E3A8A"/>
                 </a:solidFill>
                 <a:latin typeface="Calibri"/>
               </a:rPr>
-              <a:t>Person A</a:t>
+              <a:t>Max Manahl</a:t>
             </a:r>
           </a:p>
         </p:txBody>
@@ -15680,8 +15680,8 @@
         </p:nvSpPr>
         <p:spPr>
           <a:xfrm>
-            <a:off x="10454335" y="329184"/>
-            <a:ext cx="1417320" cy="384048"/>
+            <a:off x="9951415" y="329184"/>
+            <a:ext cx="1920240" cy="384048"/>
           </a:xfrm>
           <a:prstGeom prst="roundRect">
             <a:avLst>
@@ -15718,13 +15718,13 @@
               <a:buNone/>
             </a:pPr>
             <a:r>
-              <a:rPr sz="1300" b="1">
+              <a:rPr sz="1200" b="1">
                 <a:solidFill>
                   <a:srgbClr val="EA580C"/>
                 </a:solidFill>
                 <a:latin typeface="Calibri"/>
               </a:rPr>
-              <a:t>Person B</a:t>
+              <a:t>Simon Schick</a:t>
             </a:r>
           </a:p>
         </p:txBody>

</xml_diff>